<commit_message>
docs: add aka.ms/PromptKit short link
- Add aka.ms/PromptKit link to README header
- Update slide deck title and closing slides to use aka.ms/PromptKit
- Regenerate PDFs

Co-authored-by: Copilot <223556219+Copilot@users.noreply.github.com>
</commit_message>
<xml_diff>
--- a/docs/PromptKit-DeepDive.pptx
+++ b/docs/PromptKit-DeepDive.pptx
@@ -4844,7 +4844,7 @@
               </a:defRPr>
             </a:pPr>
             <a:r>
-              <a:t>github.com/microsoft/promptkit  ·  MIT License  ·  v0.2.0</a:t>
+              <a:t>aka.ms/PromptKit  ·  MIT License  ·  v0.2.0</a:t>
             </a:r>
           </a:p>
         </p:txBody>
@@ -16526,7 +16526,7 @@
               </a:defRPr>
             </a:pPr>
             <a:r>
-              <a:t>github.com/microsoft/promptkit</a:t>
+              <a:t>aka.ms/PromptKit</a:t>
             </a:r>
           </a:p>
         </p:txBody>

</xml_diff>